<commit_message>
- Organized the folders, especially the one from baseline models - Updated LFCC + Delta baseline model - Added the other models (with different features) using the LFCC as a base
</commit_message>
<xml_diff>
--- a/Team Lab Results Report - Presentation.pptx
+++ b/Team Lab Results Report - Presentation.pptx
@@ -8,6 +8,8 @@
     <p:sldId id="256" r:id="rId2"/>
     <p:sldId id="257" r:id="rId3"/>
     <p:sldId id="258" r:id="rId4"/>
+    <p:sldId id="259" r:id="rId5"/>
+    <p:sldId id="260" r:id="rId6"/>
   </p:sldIdLst>
   <p:sldSz cx="12192000" cy="6858000"/>
   <p:notesSz cx="6858000" cy="9144000"/>
@@ -106,6 +108,11 @@
       </a:defRPr>
     </a:lvl9pPr>
   </p:defaultTextStyle>
+  <p:extLst>
+    <p:ext uri="{EFAFB233-063F-42B5-8137-9DF3F51BA10A}">
+      <p15:sldGuideLst xmlns:p15="http://schemas.microsoft.com/office/powerpoint/2012/main"/>
+    </p:ext>
+  </p:extLst>
 </p:presentation>
 </file>
 
@@ -258,7 +265,7 @@
           <a:p>
             <a:fld id="{7BF1EFF9-EEB7-4840-B4A6-7D05B9478714}" type="datetimeFigureOut">
               <a:rPr lang="pt-BR" smtClean="0"/>
-              <a:t>29/06/2025</a:t>
+              <a:t>07/07/2025</a:t>
             </a:fld>
             <a:endParaRPr lang="pt-BR"/>
           </a:p>
@@ -458,7 +465,7 @@
           <a:p>
             <a:fld id="{7BF1EFF9-EEB7-4840-B4A6-7D05B9478714}" type="datetimeFigureOut">
               <a:rPr lang="pt-BR" smtClean="0"/>
-              <a:t>29/06/2025</a:t>
+              <a:t>07/07/2025</a:t>
             </a:fld>
             <a:endParaRPr lang="pt-BR"/>
           </a:p>
@@ -668,7 +675,7 @@
           <a:p>
             <a:fld id="{7BF1EFF9-EEB7-4840-B4A6-7D05B9478714}" type="datetimeFigureOut">
               <a:rPr lang="pt-BR" smtClean="0"/>
-              <a:t>29/06/2025</a:t>
+              <a:t>07/07/2025</a:t>
             </a:fld>
             <a:endParaRPr lang="pt-BR"/>
           </a:p>
@@ -868,7 +875,7 @@
           <a:p>
             <a:fld id="{7BF1EFF9-EEB7-4840-B4A6-7D05B9478714}" type="datetimeFigureOut">
               <a:rPr lang="pt-BR" smtClean="0"/>
-              <a:t>29/06/2025</a:t>
+              <a:t>07/07/2025</a:t>
             </a:fld>
             <a:endParaRPr lang="pt-BR"/>
           </a:p>
@@ -1144,7 +1151,7 @@
           <a:p>
             <a:fld id="{7BF1EFF9-EEB7-4840-B4A6-7D05B9478714}" type="datetimeFigureOut">
               <a:rPr lang="pt-BR" smtClean="0"/>
-              <a:t>29/06/2025</a:t>
+              <a:t>07/07/2025</a:t>
             </a:fld>
             <a:endParaRPr lang="pt-BR"/>
           </a:p>
@@ -1412,7 +1419,7 @@
           <a:p>
             <a:fld id="{7BF1EFF9-EEB7-4840-B4A6-7D05B9478714}" type="datetimeFigureOut">
               <a:rPr lang="pt-BR" smtClean="0"/>
-              <a:t>29/06/2025</a:t>
+              <a:t>07/07/2025</a:t>
             </a:fld>
             <a:endParaRPr lang="pt-BR"/>
           </a:p>
@@ -1827,7 +1834,7 @@
           <a:p>
             <a:fld id="{7BF1EFF9-EEB7-4840-B4A6-7D05B9478714}" type="datetimeFigureOut">
               <a:rPr lang="pt-BR" smtClean="0"/>
-              <a:t>29/06/2025</a:t>
+              <a:t>07/07/2025</a:t>
             </a:fld>
             <a:endParaRPr lang="pt-BR"/>
           </a:p>
@@ -1969,7 +1976,7 @@
           <a:p>
             <a:fld id="{7BF1EFF9-EEB7-4840-B4A6-7D05B9478714}" type="datetimeFigureOut">
               <a:rPr lang="pt-BR" smtClean="0"/>
-              <a:t>29/06/2025</a:t>
+              <a:t>07/07/2025</a:t>
             </a:fld>
             <a:endParaRPr lang="pt-BR"/>
           </a:p>
@@ -2082,7 +2089,7 @@
           <a:p>
             <a:fld id="{7BF1EFF9-EEB7-4840-B4A6-7D05B9478714}" type="datetimeFigureOut">
               <a:rPr lang="pt-BR" smtClean="0"/>
-              <a:t>29/06/2025</a:t>
+              <a:t>07/07/2025</a:t>
             </a:fld>
             <a:endParaRPr lang="pt-BR"/>
           </a:p>
@@ -2395,7 +2402,7 @@
           <a:p>
             <a:fld id="{7BF1EFF9-EEB7-4840-B4A6-7D05B9478714}" type="datetimeFigureOut">
               <a:rPr lang="pt-BR" smtClean="0"/>
-              <a:t>29/06/2025</a:t>
+              <a:t>07/07/2025</a:t>
             </a:fld>
             <a:endParaRPr lang="pt-BR"/>
           </a:p>
@@ -2684,7 +2691,7 @@
           <a:p>
             <a:fld id="{7BF1EFF9-EEB7-4840-B4A6-7D05B9478714}" type="datetimeFigureOut">
               <a:rPr lang="pt-BR" smtClean="0"/>
-              <a:t>29/06/2025</a:t>
+              <a:t>07/07/2025</a:t>
             </a:fld>
             <a:endParaRPr lang="pt-BR"/>
           </a:p>
@@ -2927,7 +2934,7 @@
           <a:p>
             <a:fld id="{7BF1EFF9-EEB7-4840-B4A6-7D05B9478714}" type="datetimeFigureOut">
               <a:rPr lang="pt-BR" smtClean="0"/>
-              <a:t>29/06/2025</a:t>
+              <a:t>07/07/2025</a:t>
             </a:fld>
             <a:endParaRPr lang="pt-BR"/>
           </a:p>
@@ -3864,6 +3871,352 @@
     <p:extLst>
       <p:ext uri="{BB962C8B-B14F-4D97-AF65-F5344CB8AC3E}">
         <p14:creationId xmlns:p14="http://schemas.microsoft.com/office/powerpoint/2010/main" val="4025491809"/>
+      </p:ext>
+    </p:extLst>
+  </p:cSld>
+  <p:clrMapOvr>
+    <a:masterClrMapping/>
+  </p:clrMapOvr>
+</p:sld>
+</file>
+
+<file path=ppt/slides/slide4.xml><?xml version="1.0" encoding="utf-8"?>
+<p:sld xmlns:a="http://schemas.openxmlformats.org/drawingml/2006/main" xmlns:r="http://schemas.openxmlformats.org/officeDocument/2006/relationships" xmlns:p="http://schemas.openxmlformats.org/presentationml/2006/main">
+  <p:cSld>
+    <p:spTree>
+      <p:nvGrpSpPr>
+        <p:cNvPr id="1" name=""/>
+        <p:cNvGrpSpPr/>
+        <p:nvPr/>
+      </p:nvGrpSpPr>
+      <p:grpSpPr>
+        <a:xfrm>
+          <a:off x="0" y="0"/>
+          <a:ext cx="0" cy="0"/>
+          <a:chOff x="0" y="0"/>
+          <a:chExt cx="0" cy="0"/>
+        </a:xfrm>
+      </p:grpSpPr>
+      <p:sp>
+        <p:nvSpPr>
+          <p:cNvPr id="2" name="Title 1">
+            <a:extLst>
+              <a:ext uri="{FF2B5EF4-FFF2-40B4-BE49-F238E27FC236}">
+                <a16:creationId xmlns:a16="http://schemas.microsoft.com/office/drawing/2014/main" id="{84805127-8829-0607-4FFD-2ED52AD5F616}"/>
+              </a:ext>
+            </a:extLst>
+          </p:cNvPr>
+          <p:cNvSpPr>
+            <a:spLocks noGrp="1"/>
+          </p:cNvSpPr>
+          <p:nvPr>
+            <p:ph type="title"/>
+          </p:nvPr>
+        </p:nvSpPr>
+        <p:spPr/>
+        <p:txBody>
+          <a:bodyPr/>
+          <a:lstStyle/>
+          <a:p>
+            <a:endParaRPr lang="en-US"/>
+          </a:p>
+        </p:txBody>
+      </p:sp>
+      <p:sp>
+        <p:nvSpPr>
+          <p:cNvPr id="3" name="Content Placeholder 2">
+            <a:extLst>
+              <a:ext uri="{FF2B5EF4-FFF2-40B4-BE49-F238E27FC236}">
+                <a16:creationId xmlns:a16="http://schemas.microsoft.com/office/drawing/2014/main" id="{72A1E96E-7A7F-B3F2-8B53-EC3FC2AD0EAE}"/>
+              </a:ext>
+            </a:extLst>
+          </p:cNvPr>
+          <p:cNvSpPr>
+            <a:spLocks noGrp="1"/>
+          </p:cNvSpPr>
+          <p:nvPr>
+            <p:ph idx="1"/>
+          </p:nvPr>
+        </p:nvSpPr>
+        <p:spPr/>
+        <p:txBody>
+          <a:bodyPr/>
+          <a:lstStyle/>
+          <a:p>
+            <a:endParaRPr lang="en-US"/>
+          </a:p>
+        </p:txBody>
+      </p:sp>
+    </p:spTree>
+    <p:extLst>
+      <p:ext uri="{BB962C8B-B14F-4D97-AF65-F5344CB8AC3E}">
+        <p14:creationId xmlns:p14="http://schemas.microsoft.com/office/powerpoint/2010/main" val="2129636024"/>
+      </p:ext>
+    </p:extLst>
+  </p:cSld>
+  <p:clrMapOvr>
+    <a:masterClrMapping/>
+  </p:clrMapOvr>
+</p:sld>
+</file>
+
+<file path=ppt/slides/slide5.xml><?xml version="1.0" encoding="utf-8"?>
+<p:sld xmlns:a="http://schemas.openxmlformats.org/drawingml/2006/main" xmlns:r="http://schemas.openxmlformats.org/officeDocument/2006/relationships" xmlns:p="http://schemas.openxmlformats.org/presentationml/2006/main">
+  <p:cSld>
+    <p:spTree>
+      <p:nvGrpSpPr>
+        <p:cNvPr id="1" name=""/>
+        <p:cNvGrpSpPr/>
+        <p:nvPr/>
+      </p:nvGrpSpPr>
+      <p:grpSpPr>
+        <a:xfrm>
+          <a:off x="0" y="0"/>
+          <a:ext cx="0" cy="0"/>
+          <a:chOff x="0" y="0"/>
+          <a:chExt cx="0" cy="0"/>
+        </a:xfrm>
+      </p:grpSpPr>
+      <p:sp>
+        <p:nvSpPr>
+          <p:cNvPr id="2" name="Title 1">
+            <a:extLst>
+              <a:ext uri="{FF2B5EF4-FFF2-40B4-BE49-F238E27FC236}">
+                <a16:creationId xmlns:a16="http://schemas.microsoft.com/office/drawing/2014/main" id="{611A3796-59F2-CFD0-2B60-2A1B7CED9383}"/>
+              </a:ext>
+            </a:extLst>
+          </p:cNvPr>
+          <p:cNvSpPr>
+            <a:spLocks noGrp="1"/>
+          </p:cNvSpPr>
+          <p:nvPr>
+            <p:ph type="title"/>
+          </p:nvPr>
+        </p:nvSpPr>
+        <p:spPr/>
+        <p:txBody>
+          <a:bodyPr/>
+          <a:lstStyle/>
+          <a:p>
+            <a:r>
+              <a:rPr lang="en-US" dirty="0"/>
+              <a:t>CNN with LFCC + Delta + Delta v5 - Results</a:t>
+            </a:r>
+            <a:endParaRPr lang="pt-BR" dirty="0"/>
+          </a:p>
+        </p:txBody>
+      </p:sp>
+      <p:graphicFrame>
+        <p:nvGraphicFramePr>
+          <p:cNvPr id="4" name="Content Placeholder 3">
+            <a:extLst>
+              <a:ext uri="{FF2B5EF4-FFF2-40B4-BE49-F238E27FC236}">
+                <a16:creationId xmlns:a16="http://schemas.microsoft.com/office/drawing/2014/main" id="{DCC23AAC-96EF-B00D-0EA6-ABBFCD818539}"/>
+              </a:ext>
+            </a:extLst>
+          </p:cNvPr>
+          <p:cNvGraphicFramePr>
+            <a:graphicFrameLocks noGrp="1"/>
+          </p:cNvGraphicFramePr>
+          <p:nvPr>
+            <p:ph idx="1"/>
+            <p:extLst>
+              <p:ext uri="{D42A27DB-BD31-4B8C-83A1-F6EECF244321}">
+                <p14:modId xmlns:p14="http://schemas.microsoft.com/office/powerpoint/2010/main" val="3442150092"/>
+              </p:ext>
+            </p:extLst>
+          </p:nvPr>
+        </p:nvGraphicFramePr>
+        <p:xfrm>
+          <a:off x="838200" y="1825625"/>
+          <a:ext cx="10515600" cy="4851400"/>
+        </p:xfrm>
+        <a:graphic>
+          <a:graphicData uri="http://schemas.openxmlformats.org/drawingml/2006/table">
+            <a:tbl>
+              <a:tblPr firstRow="1" bandRow="1">
+                <a:tableStyleId>{5C22544A-7EE6-4342-B048-85BDC9FD1C3A}</a:tableStyleId>
+              </a:tblPr>
+              <a:tblGrid>
+                <a:gridCol w="5257800">
+                  <a:extLst>
+                    <a:ext uri="{9D8B030D-6E8A-4147-A177-3AD203B41FA5}">
+                      <a16:colId xmlns:a16="http://schemas.microsoft.com/office/drawing/2014/main" val="2186543850"/>
+                    </a:ext>
+                  </a:extLst>
+                </a:gridCol>
+                <a:gridCol w="5257800">
+                  <a:extLst>
+                    <a:ext uri="{9D8B030D-6E8A-4147-A177-3AD203B41FA5}">
+                      <a16:colId xmlns:a16="http://schemas.microsoft.com/office/drawing/2014/main" val="2356058828"/>
+                    </a:ext>
+                  </a:extLst>
+                </a:gridCol>
+              </a:tblGrid>
+              <a:tr h="370840">
+                <a:tc>
+                  <a:txBody>
+                    <a:bodyPr/>
+                    <a:lstStyle/>
+                    <a:p>
+                      <a:r>
+                        <a:rPr lang="en-US" dirty="0"/>
+                        <a:t>Training Loop – Train/Val</a:t>
+                      </a:r>
+                      <a:endParaRPr lang="pt-BR" dirty="0"/>
+                    </a:p>
+                  </a:txBody>
+                  <a:tcPr/>
+                </a:tc>
+                <a:tc>
+                  <a:txBody>
+                    <a:bodyPr/>
+                    <a:lstStyle/>
+                    <a:p>
+                      <a:r>
+                        <a:rPr lang="en-US" dirty="0"/>
+                        <a:t>Test Set – Final Results</a:t>
+                      </a:r>
+                      <a:endParaRPr lang="pt-BR" dirty="0"/>
+                    </a:p>
+                  </a:txBody>
+                  <a:tcPr/>
+                </a:tc>
+                <a:extLst>
+                  <a:ext uri="{0D108BD9-81ED-4DB2-BD59-A6C34878D82A}">
+                    <a16:rowId xmlns:a16="http://schemas.microsoft.com/office/drawing/2014/main" val="732408860"/>
+                  </a:ext>
+                </a:extLst>
+              </a:tr>
+              <a:tr h="370840">
+                <a:tc>
+                  <a:txBody>
+                    <a:bodyPr/>
+                    <a:lstStyle/>
+                    <a:p>
+                      <a:r>
+                        <a:rPr lang="en-US" sz="1800" b="0" i="0" kern="1200" dirty="0">
+                          <a:solidFill>
+                            <a:schemeClr val="dk1"/>
+                          </a:solidFill>
+                          <a:effectLst/>
+                          <a:latin typeface="+mn-lt"/>
+                          <a:ea typeface="+mn-ea"/>
+                          <a:cs typeface="+mn-cs"/>
+                        </a:rPr>
+                        <a:t>Epoch [42/100] | Train Loss: 0.0405, Acc: 99.20% | Val Loss: 0.0152, Acc: 99.87% | Val EER: 0.27%</a:t>
+                      </a:r>
+                      <a:endParaRPr lang="pt-BR" dirty="0"/>
+                    </a:p>
+                  </a:txBody>
+                  <a:tcPr/>
+                </a:tc>
+                <a:tc>
+                  <a:txBody>
+                    <a:bodyPr/>
+                    <a:lstStyle/>
+                    <a:p>
+                      <a:r>
+                        <a:rPr lang="en-US" sz="1800" b="0" i="0" kern="1200" dirty="0">
+                          <a:solidFill>
+                            <a:schemeClr val="dk1"/>
+                          </a:solidFill>
+                          <a:effectLst/>
+                          <a:latin typeface="+mn-lt"/>
+                          <a:ea typeface="+mn-ea"/>
+                          <a:cs typeface="+mn-cs"/>
+                        </a:rPr>
+                        <a:t>Evaluation Set: Loss: 0.9477 | Accuracy: 69.27% EER: 7.42% | Logit Threshold: 4.3701 | Prob Threshold: 0.9875 F1 Score: 0.7203 Precision: 0.5895 Recall: 0.9258 Predictions: [1]: 11550 | [0]: 59687</a:t>
+                      </a:r>
+                    </a:p>
+                    <a:p>
+                      <a:endParaRPr lang="en-US" sz="1800" b="0" i="0" kern="1200" dirty="0">
+                        <a:solidFill>
+                          <a:schemeClr val="dk1"/>
+                        </a:solidFill>
+                        <a:effectLst/>
+                        <a:latin typeface="+mn-lt"/>
+                        <a:ea typeface="+mn-ea"/>
+                        <a:cs typeface="+mn-cs"/>
+                      </a:endParaRPr>
+                    </a:p>
+                    <a:p>
+                      <a:endParaRPr lang="pt-BR" dirty="0"/>
+                    </a:p>
+                    <a:p>
+                      <a:endParaRPr lang="pt-BR" dirty="0"/>
+                    </a:p>
+                    <a:p>
+                      <a:endParaRPr lang="pt-BR" dirty="0"/>
+                    </a:p>
+                    <a:p>
+                      <a:endParaRPr lang="pt-BR" dirty="0"/>
+                    </a:p>
+                    <a:p>
+                      <a:endParaRPr lang="pt-BR" dirty="0"/>
+                    </a:p>
+                    <a:p>
+                      <a:endParaRPr lang="pt-BR" dirty="0"/>
+                    </a:p>
+                    <a:p>
+                      <a:endParaRPr lang="pt-BR" dirty="0"/>
+                    </a:p>
+                    <a:p>
+                      <a:endParaRPr lang="pt-BR" dirty="0"/>
+                    </a:p>
+                    <a:p>
+                      <a:endParaRPr lang="pt-BR" dirty="0"/>
+                    </a:p>
+                    <a:p>
+                      <a:endParaRPr lang="pt-BR" dirty="0"/>
+                    </a:p>
+                  </a:txBody>
+                  <a:tcPr/>
+                </a:tc>
+                <a:extLst>
+                  <a:ext uri="{0D108BD9-81ED-4DB2-BD59-A6C34878D82A}">
+                    <a16:rowId xmlns:a16="http://schemas.microsoft.com/office/drawing/2014/main" val="416856037"/>
+                  </a:ext>
+                </a:extLst>
+              </a:tr>
+            </a:tbl>
+          </a:graphicData>
+        </a:graphic>
+      </p:graphicFrame>
+      <p:pic>
+        <p:nvPicPr>
+          <p:cNvPr id="5" name="Picture 4">
+            <a:extLst>
+              <a:ext uri="{FF2B5EF4-FFF2-40B4-BE49-F238E27FC236}">
+                <a16:creationId xmlns:a16="http://schemas.microsoft.com/office/drawing/2014/main" id="{AFB2D557-7F73-15DB-6D8C-39804AA821EC}"/>
+              </a:ext>
+            </a:extLst>
+          </p:cNvPr>
+          <p:cNvPicPr>
+            <a:picLocks noChangeAspect="1"/>
+          </p:cNvPicPr>
+          <p:nvPr/>
+        </p:nvPicPr>
+        <p:blipFill>
+          <a:blip r:embed="rId2"/>
+          <a:stretch>
+            <a:fillRect/>
+          </a:stretch>
+        </p:blipFill>
+        <p:spPr>
+          <a:xfrm>
+            <a:off x="7272338" y="3900049"/>
+            <a:ext cx="2916691" cy="2486463"/>
+          </a:xfrm>
+          <a:prstGeom prst="rect">
+            <a:avLst/>
+          </a:prstGeom>
+        </p:spPr>
+      </p:pic>
+    </p:spTree>
+    <p:extLst>
+      <p:ext uri="{BB962C8B-B14F-4D97-AF65-F5344CB8AC3E}">
+        <p14:creationId xmlns:p14="http://schemas.microsoft.com/office/powerpoint/2010/main" val="3077883766"/>
       </p:ext>
     </p:extLst>
   </p:cSld>

</xml_diff>